<commit_message>
Trauma and Emergency Care
</commit_message>
<xml_diff>
--- a/colleges/kmtc/diploma/Diploma in Kenya Registered Community Health Nursing/Year 1/Trauma, Emergency and Basic Life Support/01-Course Materials/Introduction to traumatology (1).pptx
+++ b/colleges/kmtc/diploma/Diploma in Kenya Registered Community Health Nursing/Year 1/Trauma, Emergency and Basic Life Support/01-Course Materials/Introduction to traumatology (1).pptx
@@ -1,29 +1,29 @@
 
 <file path=ppt/presentation.xml><?xml version="1.0" encoding="utf-8"?>
-<p:presentation xmlns:a="http://schemas.openxmlformats.org/drawingml/2006/main" xmlns:r="http://schemas.openxmlformats.org/officeDocument/2006/relationships" xmlns:p="http://schemas.openxmlformats.org/presentationml/2006/main" saveSubsetFonts="1">
+<p:presentation xmlns:a="http://schemas.openxmlformats.org/drawingml/2006/main" xmlns:r="http://schemas.openxmlformats.org/officeDocument/2006/relationships" xmlns:p="http://schemas.openxmlformats.org/presentationml/2006/main">
   <p:sldMasterIdLst>
-    <p:sldMasterId id="2147483660" r:id="rId1"/>
+    <p:sldMasterId id="2147483648" r:id="rId1"/>
   </p:sldMasterIdLst>
   <p:sldIdLst>
-    <p:sldId id="256" r:id="rId2"/>
-    <p:sldId id="257" r:id="rId3"/>
-    <p:sldId id="273" r:id="rId4"/>
-    <p:sldId id="258" r:id="rId5"/>
-    <p:sldId id="260" r:id="rId6"/>
-    <p:sldId id="261" r:id="rId7"/>
-    <p:sldId id="259" r:id="rId8"/>
-    <p:sldId id="262" r:id="rId9"/>
-    <p:sldId id="263" r:id="rId10"/>
-    <p:sldId id="264" r:id="rId11"/>
-    <p:sldId id="275" r:id="rId12"/>
-    <p:sldId id="265" r:id="rId13"/>
-    <p:sldId id="266" r:id="rId14"/>
-    <p:sldId id="268" r:id="rId15"/>
-    <p:sldId id="269" r:id="rId16"/>
-    <p:sldId id="270" r:id="rId17"/>
-    <p:sldId id="271" r:id="rId18"/>
-    <p:sldId id="274" r:id="rId19"/>
-    <p:sldId id="272" r:id="rId20"/>
+    <p:sldId id="256" r:id="rId3"/>
+    <p:sldId id="257" r:id="rId4"/>
+    <p:sldId id="273" r:id="rId5"/>
+    <p:sldId id="258" r:id="rId6"/>
+    <p:sldId id="260" r:id="rId7"/>
+    <p:sldId id="261" r:id="rId8"/>
+    <p:sldId id="259" r:id="rId9"/>
+    <p:sldId id="262" r:id="rId10"/>
+    <p:sldId id="263" r:id="rId11"/>
+    <p:sldId id="264" r:id="rId12"/>
+    <p:sldId id="275" r:id="rId13"/>
+    <p:sldId id="265" r:id="rId14"/>
+    <p:sldId id="266" r:id="rId15"/>
+    <p:sldId id="268" r:id="rId16"/>
+    <p:sldId id="269" r:id="rId17"/>
+    <p:sldId id="270" r:id="rId18"/>
+    <p:sldId id="271" r:id="rId19"/>
+    <p:sldId id="274" r:id="rId20"/>
+    <p:sldId id="272" r:id="rId21"/>
   </p:sldIdLst>
   <p:sldSz cx="12192000" cy="6858000"/>
   <p:notesSz cx="6858000" cy="9144000"/>
@@ -122,16 +122,11 @@
       </a:defRPr>
     </a:lvl9pPr>
   </p:defaultTextStyle>
-  <p:extLst>
-    <p:ext uri="{EFAFB233-063F-42B5-8137-9DF3F51BA10A}">
-      <p15:sldGuideLst xmlns:p15="http://schemas.microsoft.com/office/powerpoint/2012/main"/>
-    </p:ext>
-  </p:extLst>
 </p:presentation>
 </file>
 
 <file path=ppt/slideLayouts/slideLayout1.xml><?xml version="1.0" encoding="utf-8"?>
-<p:sldLayout xmlns:a="http://schemas.openxmlformats.org/drawingml/2006/main" xmlns:r="http://schemas.openxmlformats.org/officeDocument/2006/relationships" xmlns:p="http://schemas.openxmlformats.org/presentationml/2006/main" showMasterSp="0" type="title" preserve="1">
+<p:sldLayout xmlns:a="http://schemas.openxmlformats.org/drawingml/2006/main" xmlns:r="http://schemas.openxmlformats.org/officeDocument/2006/relationships" xmlns:p="http://schemas.openxmlformats.org/presentationml/2006/main" type="title" preserve="1" showMasterSp="0">
   <p:cSld name="Title Slide">
     <p:bg>
       <p:bgRef idx="1001">
@@ -346,6 +341,7 @@
               <a:rPr lang="en-US"/>
               <a:t>Click to edit Master title style</a:t>
             </a:r>
+            <a:endParaRPr lang="en-US"/>
           </a:p>
         </p:txBody>
       </p:sp>
@@ -408,6 +404,7 @@
               <a:rPr lang="en-US"/>
               <a:t>Click to edit Master subtitle style</a:t>
             </a:r>
+            <a:endParaRPr lang="en-US"/>
           </a:p>
         </p:txBody>
       </p:sp>
@@ -443,7 +440,6 @@
           <a:p>
             <a:fld id="{B51AB6BE-0945-437C-998D-2F62DBC41F2B}" type="datetimeFigureOut">
               <a:rPr lang="en-US" smtClean="0"/>
-              <a:t>3/17/2023</a:t>
             </a:fld>
             <a:endParaRPr lang="en-US"/>
           </a:p>
@@ -511,18 +507,12 @@
           <a:p>
             <a:fld id="{8E054A1B-CB68-4761-8B43-A0576DD5869E}" type="slidenum">
               <a:rPr lang="en-US" smtClean="0"/>
-              <a:t>‹#›</a:t>
             </a:fld>
             <a:endParaRPr lang="en-US"/>
           </a:p>
         </p:txBody>
       </p:sp>
     </p:spTree>
-    <p:extLst>
-      <p:ext uri="{BB962C8B-B14F-4D97-AF65-F5344CB8AC3E}">
-        <p14:creationId xmlns:p14="http://schemas.microsoft.com/office/powerpoint/2010/main" val="2897152425"/>
-      </p:ext>
-    </p:extLst>
   </p:cSld>
   <p:clrMapOvr>
     <a:overrideClrMapping bg1="dk1" tx1="lt1" bg2="dk2" tx2="lt2" accent1="accent1" accent2="accent2" accent3="accent3" accent4="accent4" accent5="accent5" accent6="accent6" hlink="hlink" folHlink="folHlink"/>
@@ -566,6 +556,7 @@
               <a:rPr lang="en-US"/>
               <a:t>Click to edit Master title style</a:t>
             </a:r>
+            <a:endParaRPr lang="en-US"/>
           </a:p>
         </p:txBody>
       </p:sp>
@@ -589,6 +580,7 @@
               <a:rPr lang="en-US"/>
               <a:t>Click to edit Master text styles</a:t>
             </a:r>
+            <a:endParaRPr lang="en-US"/>
           </a:p>
           <a:p>
             <a:pPr lvl="1"/>
@@ -596,6 +588,7 @@
               <a:rPr lang="en-US"/>
               <a:t>Second level</a:t>
             </a:r>
+            <a:endParaRPr lang="en-US"/>
           </a:p>
           <a:p>
             <a:pPr lvl="2"/>
@@ -603,6 +596,7 @@
               <a:rPr lang="en-US"/>
               <a:t>Third level</a:t>
             </a:r>
+            <a:endParaRPr lang="en-US"/>
           </a:p>
           <a:p>
             <a:pPr lvl="3"/>
@@ -610,6 +604,7 @@
               <a:rPr lang="en-US"/>
               <a:t>Fourth level</a:t>
             </a:r>
+            <a:endParaRPr lang="en-US"/>
           </a:p>
           <a:p>
             <a:pPr lvl="4"/>
@@ -617,6 +612,7 @@
               <a:rPr lang="en-US"/>
               <a:t>Fifth level</a:t>
             </a:r>
+            <a:endParaRPr lang="en-US"/>
           </a:p>
         </p:txBody>
       </p:sp>
@@ -641,7 +637,6 @@
           <a:p>
             <a:fld id="{B51AB6BE-0945-437C-998D-2F62DBC41F2B}" type="datetimeFigureOut">
               <a:rPr lang="en-US" smtClean="0"/>
-              <a:t>3/17/2023</a:t>
             </a:fld>
             <a:endParaRPr lang="en-US"/>
           </a:p>
@@ -691,18 +686,12 @@
           <a:p>
             <a:fld id="{8E054A1B-CB68-4761-8B43-A0576DD5869E}" type="slidenum">
               <a:rPr lang="en-US" smtClean="0"/>
-              <a:t>‹#›</a:t>
             </a:fld>
             <a:endParaRPr lang="en-US"/>
           </a:p>
         </p:txBody>
       </p:sp>
     </p:spTree>
-    <p:extLst>
-      <p:ext uri="{BB962C8B-B14F-4D97-AF65-F5344CB8AC3E}">
-        <p14:creationId xmlns:p14="http://schemas.microsoft.com/office/powerpoint/2010/main" val="52818392"/>
-      </p:ext>
-    </p:extLst>
   </p:cSld>
   <p:clrMapOvr>
     <a:masterClrMapping/>
@@ -711,7 +700,7 @@
 </file>
 
 <file path=ppt/slideLayouts/slideLayout11.xml><?xml version="1.0" encoding="utf-8"?>
-<p:sldLayout xmlns:a="http://schemas.openxmlformats.org/drawingml/2006/main" xmlns:r="http://schemas.openxmlformats.org/officeDocument/2006/relationships" xmlns:p="http://schemas.openxmlformats.org/presentationml/2006/main" showMasterSp="0" type="vertTitleAndTx" preserve="1">
+<p:sldLayout xmlns:a="http://schemas.openxmlformats.org/drawingml/2006/main" xmlns:r="http://schemas.openxmlformats.org/officeDocument/2006/relationships" xmlns:p="http://schemas.openxmlformats.org/presentationml/2006/main" type="vertTitleAndTx" preserve="1" showMasterSp="0">
   <p:cSld name="Vertical Title and Text">
     <p:spTree>
       <p:nvGrpSpPr>
@@ -910,6 +899,7 @@
               <a:rPr lang="en-US"/>
               <a:t>Click to edit Master title style</a:t>
             </a:r>
+            <a:endParaRPr lang="en-US"/>
           </a:p>
         </p:txBody>
       </p:sp>
@@ -938,6 +928,7 @@
               <a:rPr lang="en-US"/>
               <a:t>Click to edit Master text styles</a:t>
             </a:r>
+            <a:endParaRPr lang="en-US"/>
           </a:p>
           <a:p>
             <a:pPr lvl="1"/>
@@ -945,6 +936,7 @@
               <a:rPr lang="en-US"/>
               <a:t>Second level</a:t>
             </a:r>
+            <a:endParaRPr lang="en-US"/>
           </a:p>
           <a:p>
             <a:pPr lvl="2"/>
@@ -952,6 +944,7 @@
               <a:rPr lang="en-US"/>
               <a:t>Third level</a:t>
             </a:r>
+            <a:endParaRPr lang="en-US"/>
           </a:p>
           <a:p>
             <a:pPr lvl="3"/>
@@ -959,6 +952,7 @@
               <a:rPr lang="en-US"/>
               <a:t>Fourth level</a:t>
             </a:r>
+            <a:endParaRPr lang="en-US"/>
           </a:p>
           <a:p>
             <a:pPr lvl="4"/>
@@ -966,6 +960,7 @@
               <a:rPr lang="en-US"/>
               <a:t>Fifth level</a:t>
             </a:r>
+            <a:endParaRPr lang="en-US"/>
           </a:p>
         </p:txBody>
       </p:sp>
@@ -995,7 +990,6 @@
           <a:p>
             <a:fld id="{B51AB6BE-0945-437C-998D-2F62DBC41F2B}" type="datetimeFigureOut">
               <a:rPr lang="en-US" smtClean="0"/>
-              <a:t>3/17/2023</a:t>
             </a:fld>
             <a:endParaRPr lang="en-US"/>
           </a:p>
@@ -1055,18 +1049,12 @@
           <a:p>
             <a:fld id="{8E054A1B-CB68-4761-8B43-A0576DD5869E}" type="slidenum">
               <a:rPr lang="en-US" smtClean="0"/>
-              <a:t>‹#›</a:t>
             </a:fld>
             <a:endParaRPr lang="en-US"/>
           </a:p>
         </p:txBody>
       </p:sp>
     </p:spTree>
-    <p:extLst>
-      <p:ext uri="{BB962C8B-B14F-4D97-AF65-F5344CB8AC3E}">
-        <p14:creationId xmlns:p14="http://schemas.microsoft.com/office/powerpoint/2010/main" val="1504102714"/>
-      </p:ext>
-    </p:extLst>
   </p:cSld>
   <p:clrMapOvr>
     <a:overrideClrMapping bg1="lt1" tx1="dk1" bg2="lt2" tx2="dk2" accent1="accent1" accent2="accent2" accent3="accent3" accent4="accent4" accent5="accent5" accent6="accent6" hlink="hlink" folHlink="folHlink"/>
@@ -1115,6 +1103,7 @@
               <a:rPr lang="en-US"/>
               <a:t>Click to edit Master title style</a:t>
             </a:r>
+            <a:endParaRPr lang="en-US"/>
           </a:p>
         </p:txBody>
       </p:sp>
@@ -1143,6 +1132,7 @@
               <a:rPr lang="en-US"/>
               <a:t>Click to edit Master text styles</a:t>
             </a:r>
+            <a:endParaRPr lang="en-US"/>
           </a:p>
           <a:p>
             <a:pPr lvl="1"/>
@@ -1150,6 +1140,7 @@
               <a:rPr lang="en-US"/>
               <a:t>Second level</a:t>
             </a:r>
+            <a:endParaRPr lang="en-US"/>
           </a:p>
           <a:p>
             <a:pPr lvl="2"/>
@@ -1157,6 +1148,7 @@
               <a:rPr lang="en-US"/>
               <a:t>Third level</a:t>
             </a:r>
+            <a:endParaRPr lang="en-US"/>
           </a:p>
           <a:p>
             <a:pPr lvl="3"/>
@@ -1164,6 +1156,7 @@
               <a:rPr lang="en-US"/>
               <a:t>Fourth level</a:t>
             </a:r>
+            <a:endParaRPr lang="en-US"/>
           </a:p>
           <a:p>
             <a:pPr lvl="4"/>
@@ -1171,6 +1164,7 @@
               <a:rPr lang="en-US"/>
               <a:t>Fifth level</a:t>
             </a:r>
+            <a:endParaRPr lang="en-US"/>
           </a:p>
         </p:txBody>
       </p:sp>
@@ -1195,7 +1189,6 @@
           <a:p>
             <a:fld id="{B51AB6BE-0945-437C-998D-2F62DBC41F2B}" type="datetimeFigureOut">
               <a:rPr lang="en-US" smtClean="0"/>
-              <a:t>3/17/2023</a:t>
             </a:fld>
             <a:endParaRPr lang="en-US"/>
           </a:p>
@@ -1245,18 +1238,12 @@
           <a:p>
             <a:fld id="{8E054A1B-CB68-4761-8B43-A0576DD5869E}" type="slidenum">
               <a:rPr lang="en-US" smtClean="0"/>
-              <a:t>‹#›</a:t>
             </a:fld>
             <a:endParaRPr lang="en-US"/>
           </a:p>
         </p:txBody>
       </p:sp>
     </p:spTree>
-    <p:extLst>
-      <p:ext uri="{BB962C8B-B14F-4D97-AF65-F5344CB8AC3E}">
-        <p14:creationId xmlns:p14="http://schemas.microsoft.com/office/powerpoint/2010/main" val="2309979505"/>
-      </p:ext>
-    </p:extLst>
   </p:cSld>
   <p:clrMapOvr>
     <a:masterClrMapping/>
@@ -1265,7 +1252,7 @@
 </file>
 
 <file path=ppt/slideLayouts/slideLayout3.xml><?xml version="1.0" encoding="utf-8"?>
-<p:sldLayout xmlns:a="http://schemas.openxmlformats.org/drawingml/2006/main" xmlns:r="http://schemas.openxmlformats.org/officeDocument/2006/relationships" xmlns:p="http://schemas.openxmlformats.org/presentationml/2006/main" showMasterSp="0" type="secHead" preserve="1">
+<p:sldLayout xmlns:a="http://schemas.openxmlformats.org/drawingml/2006/main" xmlns:r="http://schemas.openxmlformats.org/officeDocument/2006/relationships" xmlns:p="http://schemas.openxmlformats.org/presentationml/2006/main" type="secHead" preserve="1" showMasterSp="0">
   <p:cSld name="Section Header">
     <p:bg>
       <p:bgRef idx="1003">
@@ -1526,6 +1513,7 @@
               <a:rPr lang="en-US"/>
               <a:t>Click to edit Master text styles</a:t>
             </a:r>
+            <a:endParaRPr lang="en-US"/>
           </a:p>
         </p:txBody>
       </p:sp>
@@ -1562,6 +1550,7 @@
               <a:rPr lang="en-US"/>
               <a:t>Click to edit Master title style</a:t>
             </a:r>
+            <a:endParaRPr lang="en-US"/>
           </a:p>
         </p:txBody>
       </p:sp>
@@ -1586,7 +1575,6 @@
           <a:p>
             <a:fld id="{B51AB6BE-0945-437C-998D-2F62DBC41F2B}" type="datetimeFigureOut">
               <a:rPr lang="en-US" smtClean="0"/>
-              <a:t>3/17/2023</a:t>
             </a:fld>
             <a:endParaRPr lang="en-US"/>
           </a:p>
@@ -1620,7 +1608,6 @@
           <a:p>
             <a:fld id="{8E054A1B-CB68-4761-8B43-A0576DD5869E}" type="slidenum">
               <a:rPr lang="en-US" smtClean="0"/>
-              <a:t>‹#›</a:t>
             </a:fld>
             <a:endParaRPr lang="en-US"/>
           </a:p>
@@ -1650,11 +1637,6 @@
         </p:txBody>
       </p:sp>
     </p:spTree>
-    <p:extLst>
-      <p:ext uri="{BB962C8B-B14F-4D97-AF65-F5344CB8AC3E}">
-        <p14:creationId xmlns:p14="http://schemas.microsoft.com/office/powerpoint/2010/main" val="4118534722"/>
-      </p:ext>
-    </p:extLst>
   </p:cSld>
   <p:clrMapOvr>
     <a:overrideClrMapping bg1="lt1" tx1="dk1" bg2="lt2" tx2="dk2" accent1="accent1" accent2="accent2" accent3="accent3" accent4="accent4" accent5="accent5" accent6="accent6" hlink="hlink" folHlink="folHlink"/>
@@ -1698,6 +1680,7 @@
               <a:rPr lang="en-US"/>
               <a:t>Click to edit Master title style</a:t>
             </a:r>
+            <a:endParaRPr lang="en-US"/>
           </a:p>
         </p:txBody>
       </p:sp>
@@ -1726,6 +1709,7 @@
               <a:rPr lang="en-US"/>
               <a:t>Click to edit Master text styles</a:t>
             </a:r>
+            <a:endParaRPr lang="en-US"/>
           </a:p>
           <a:p>
             <a:pPr lvl="1"/>
@@ -1733,6 +1717,7 @@
               <a:rPr lang="en-US"/>
               <a:t>Second level</a:t>
             </a:r>
+            <a:endParaRPr lang="en-US"/>
           </a:p>
           <a:p>
             <a:pPr lvl="2"/>
@@ -1740,6 +1725,7 @@
               <a:rPr lang="en-US"/>
               <a:t>Third level</a:t>
             </a:r>
+            <a:endParaRPr lang="en-US"/>
           </a:p>
           <a:p>
             <a:pPr lvl="3"/>
@@ -1747,6 +1733,7 @@
               <a:rPr lang="en-US"/>
               <a:t>Fourth level</a:t>
             </a:r>
+            <a:endParaRPr lang="en-US"/>
           </a:p>
           <a:p>
             <a:pPr lvl="4"/>
@@ -1754,6 +1741,7 @@
               <a:rPr lang="en-US"/>
               <a:t>Fifth level</a:t>
             </a:r>
+            <a:endParaRPr lang="en-US"/>
           </a:p>
         </p:txBody>
       </p:sp>
@@ -1782,6 +1770,7 @@
               <a:rPr lang="en-US"/>
               <a:t>Click to edit Master text styles</a:t>
             </a:r>
+            <a:endParaRPr lang="en-US"/>
           </a:p>
           <a:p>
             <a:pPr lvl="1"/>
@@ -1789,6 +1778,7 @@
               <a:rPr lang="en-US"/>
               <a:t>Second level</a:t>
             </a:r>
+            <a:endParaRPr lang="en-US"/>
           </a:p>
           <a:p>
             <a:pPr lvl="2"/>
@@ -1796,6 +1786,7 @@
               <a:rPr lang="en-US"/>
               <a:t>Third level</a:t>
             </a:r>
+            <a:endParaRPr lang="en-US"/>
           </a:p>
           <a:p>
             <a:pPr lvl="3"/>
@@ -1803,6 +1794,7 @@
               <a:rPr lang="en-US"/>
               <a:t>Fourth level</a:t>
             </a:r>
+            <a:endParaRPr lang="en-US"/>
           </a:p>
           <a:p>
             <a:pPr lvl="4"/>
@@ -1810,6 +1802,7 @@
               <a:rPr lang="en-US"/>
               <a:t>Fifth level</a:t>
             </a:r>
+            <a:endParaRPr lang="en-US"/>
           </a:p>
         </p:txBody>
       </p:sp>
@@ -1834,7 +1827,6 @@
           <a:p>
             <a:fld id="{B51AB6BE-0945-437C-998D-2F62DBC41F2B}" type="datetimeFigureOut">
               <a:rPr lang="en-US" smtClean="0"/>
-              <a:t>3/17/2023</a:t>
             </a:fld>
             <a:endParaRPr lang="en-US"/>
           </a:p>
@@ -1861,7 +1853,6 @@
           <a:p>
             <a:fld id="{8E054A1B-CB68-4761-8B43-A0576DD5869E}" type="slidenum">
               <a:rPr lang="en-US" smtClean="0"/>
-              <a:t>‹#›</a:t>
             </a:fld>
             <a:endParaRPr lang="en-US"/>
           </a:p>
@@ -1891,11 +1882,6 @@
         </p:txBody>
       </p:sp>
     </p:spTree>
-    <p:extLst>
-      <p:ext uri="{BB962C8B-B14F-4D97-AF65-F5344CB8AC3E}">
-        <p14:creationId xmlns:p14="http://schemas.microsoft.com/office/powerpoint/2010/main" val="2913647370"/>
-      </p:ext>
-    </p:extLst>
   </p:cSld>
   <p:clrMapOvr>
     <a:masterClrMapping/>
@@ -1948,6 +1934,7 @@
               <a:rPr lang="en-US"/>
               <a:t>Click to edit Master title style</a:t>
             </a:r>
+            <a:endParaRPr lang="en-US"/>
           </a:p>
         </p:txBody>
       </p:sp>
@@ -1976,6 +1963,7 @@
               <a:rPr lang="en-US"/>
               <a:t>Click to edit Master text styles</a:t>
             </a:r>
+            <a:endParaRPr lang="en-US"/>
           </a:p>
           <a:p>
             <a:pPr lvl="1"/>
@@ -1983,6 +1971,7 @@
               <a:rPr lang="en-US"/>
               <a:t>Second level</a:t>
             </a:r>
+            <a:endParaRPr lang="en-US"/>
           </a:p>
           <a:p>
             <a:pPr lvl="2"/>
@@ -1990,6 +1979,7 @@
               <a:rPr lang="en-US"/>
               <a:t>Third level</a:t>
             </a:r>
+            <a:endParaRPr lang="en-US"/>
           </a:p>
           <a:p>
             <a:pPr lvl="3"/>
@@ -1997,6 +1987,7 @@
               <a:rPr lang="en-US"/>
               <a:t>Fourth level</a:t>
             </a:r>
+            <a:endParaRPr lang="en-US"/>
           </a:p>
           <a:p>
             <a:pPr lvl="4"/>
@@ -2004,6 +1995,7 @@
               <a:rPr lang="en-US"/>
               <a:t>Fifth level</a:t>
             </a:r>
+            <a:endParaRPr lang="en-US"/>
           </a:p>
         </p:txBody>
       </p:sp>
@@ -2032,6 +2024,7 @@
               <a:rPr lang="en-US"/>
               <a:t>Click to edit Master text styles</a:t>
             </a:r>
+            <a:endParaRPr lang="en-US"/>
           </a:p>
           <a:p>
             <a:pPr lvl="1"/>
@@ -2039,6 +2032,7 @@
               <a:rPr lang="en-US"/>
               <a:t>Second level</a:t>
             </a:r>
+            <a:endParaRPr lang="en-US"/>
           </a:p>
           <a:p>
             <a:pPr lvl="2"/>
@@ -2046,6 +2040,7 @@
               <a:rPr lang="en-US"/>
               <a:t>Third level</a:t>
             </a:r>
+            <a:endParaRPr lang="en-US"/>
           </a:p>
           <a:p>
             <a:pPr lvl="3"/>
@@ -2053,6 +2048,7 @@
               <a:rPr lang="en-US"/>
               <a:t>Fourth level</a:t>
             </a:r>
+            <a:endParaRPr lang="en-US"/>
           </a:p>
           <a:p>
             <a:pPr lvl="4"/>
@@ -2060,6 +2056,7 @@
               <a:rPr lang="en-US"/>
               <a:t>Fifth level</a:t>
             </a:r>
+            <a:endParaRPr lang="en-US"/>
           </a:p>
         </p:txBody>
       </p:sp>
@@ -2101,6 +2098,7 @@
               <a:rPr lang="en-US"/>
               <a:t>Click to edit Master text styles</a:t>
             </a:r>
+            <a:endParaRPr lang="en-US"/>
           </a:p>
         </p:txBody>
       </p:sp>
@@ -2142,6 +2140,7 @@
               <a:rPr lang="en-US"/>
               <a:t>Click to edit Master text styles</a:t>
             </a:r>
+            <a:endParaRPr lang="en-US"/>
           </a:p>
         </p:txBody>
       </p:sp>
@@ -2166,7 +2165,6 @@
           <a:p>
             <a:fld id="{B51AB6BE-0945-437C-998D-2F62DBC41F2B}" type="datetimeFigureOut">
               <a:rPr lang="en-US" smtClean="0"/>
-              <a:t>3/17/2023</a:t>
             </a:fld>
             <a:endParaRPr lang="en-US"/>
           </a:p>
@@ -2193,7 +2191,6 @@
           <a:p>
             <a:fld id="{8E054A1B-CB68-4761-8B43-A0576DD5869E}" type="slidenum">
               <a:rPr lang="en-US" smtClean="0"/>
-              <a:t>‹#›</a:t>
             </a:fld>
             <a:endParaRPr lang="en-US"/>
           </a:p>
@@ -2223,11 +2220,6 @@
         </p:txBody>
       </p:sp>
     </p:spTree>
-    <p:extLst>
-      <p:ext uri="{BB962C8B-B14F-4D97-AF65-F5344CB8AC3E}">
-        <p14:creationId xmlns:p14="http://schemas.microsoft.com/office/powerpoint/2010/main" val="902276728"/>
-      </p:ext>
-    </p:extLst>
   </p:cSld>
   <p:clrMapOvr>
     <a:masterClrMapping/>
@@ -2271,6 +2263,7 @@
               <a:rPr lang="en-US"/>
               <a:t>Click to edit Master title style</a:t>
             </a:r>
+            <a:endParaRPr lang="en-US"/>
           </a:p>
         </p:txBody>
       </p:sp>
@@ -2295,7 +2288,6 @@
           <a:p>
             <a:fld id="{B51AB6BE-0945-437C-998D-2F62DBC41F2B}" type="datetimeFigureOut">
               <a:rPr lang="en-US" smtClean="0"/>
-              <a:t>3/17/2023</a:t>
             </a:fld>
             <a:endParaRPr lang="en-US"/>
           </a:p>
@@ -2345,18 +2337,12 @@
           <a:p>
             <a:fld id="{8E054A1B-CB68-4761-8B43-A0576DD5869E}" type="slidenum">
               <a:rPr lang="en-US" smtClean="0"/>
-              <a:t>‹#›</a:t>
             </a:fld>
             <a:endParaRPr lang="en-US"/>
           </a:p>
         </p:txBody>
       </p:sp>
     </p:spTree>
-    <p:extLst>
-      <p:ext uri="{BB962C8B-B14F-4D97-AF65-F5344CB8AC3E}">
-        <p14:creationId xmlns:p14="http://schemas.microsoft.com/office/powerpoint/2010/main" val="1720078452"/>
-      </p:ext>
-    </p:extLst>
   </p:cSld>
   <p:clrMapOvr>
     <a:masterClrMapping/>
@@ -2365,7 +2351,7 @@
 </file>
 
 <file path=ppt/slideLayouts/slideLayout7.xml><?xml version="1.0" encoding="utf-8"?>
-<p:sldLayout xmlns:a="http://schemas.openxmlformats.org/drawingml/2006/main" xmlns:r="http://schemas.openxmlformats.org/officeDocument/2006/relationships" xmlns:p="http://schemas.openxmlformats.org/presentationml/2006/main" showMasterSp="0" type="blank" preserve="1">
+<p:sldLayout xmlns:a="http://schemas.openxmlformats.org/drawingml/2006/main" xmlns:r="http://schemas.openxmlformats.org/officeDocument/2006/relationships" xmlns:p="http://schemas.openxmlformats.org/presentationml/2006/main" type="blank" preserve="1" showMasterSp="0">
   <p:cSld name="Blank">
     <p:spTree>
       <p:nvGrpSpPr>
@@ -2402,7 +2388,6 @@
           <a:p>
             <a:fld id="{B51AB6BE-0945-437C-998D-2F62DBC41F2B}" type="datetimeFigureOut">
               <a:rPr lang="en-US" smtClean="0"/>
-              <a:t>3/17/2023</a:t>
             </a:fld>
             <a:endParaRPr lang="en-US"/>
           </a:p>
@@ -2461,18 +2446,12 @@
           <a:p>
             <a:fld id="{8E054A1B-CB68-4761-8B43-A0576DD5869E}" type="slidenum">
               <a:rPr lang="en-US" smtClean="0"/>
-              <a:t>‹#›</a:t>
             </a:fld>
             <a:endParaRPr lang="en-US"/>
           </a:p>
         </p:txBody>
       </p:sp>
     </p:spTree>
-    <p:extLst>
-      <p:ext uri="{BB962C8B-B14F-4D97-AF65-F5344CB8AC3E}">
-        <p14:creationId xmlns:p14="http://schemas.microsoft.com/office/powerpoint/2010/main" val="3939462970"/>
-      </p:ext>
-    </p:extLst>
   </p:cSld>
   <p:clrMapOvr>
     <a:masterClrMapping/>
@@ -2526,6 +2505,7 @@
               <a:rPr lang="en-US"/>
               <a:t>Click to edit Master title style</a:t>
             </a:r>
+            <a:endParaRPr lang="en-US"/>
           </a:p>
         </p:txBody>
       </p:sp>
@@ -2600,6 +2580,7 @@
               <a:rPr lang="en-US"/>
               <a:t>Click to edit Master text styles</a:t>
             </a:r>
+            <a:endParaRPr lang="en-US"/>
           </a:p>
         </p:txBody>
       </p:sp>
@@ -2628,6 +2609,7 @@
               <a:rPr lang="en-US"/>
               <a:t>Click to edit Master text styles</a:t>
             </a:r>
+            <a:endParaRPr lang="en-US"/>
           </a:p>
           <a:p>
             <a:pPr lvl="1"/>
@@ -2635,6 +2617,7 @@
               <a:rPr lang="en-US"/>
               <a:t>Second level</a:t>
             </a:r>
+            <a:endParaRPr lang="en-US"/>
           </a:p>
           <a:p>
             <a:pPr lvl="2"/>
@@ -2642,6 +2625,7 @@
               <a:rPr lang="en-US"/>
               <a:t>Third level</a:t>
             </a:r>
+            <a:endParaRPr lang="en-US"/>
           </a:p>
           <a:p>
             <a:pPr lvl="3"/>
@@ -2649,6 +2633,7 @@
               <a:rPr lang="en-US"/>
               <a:t>Fourth level</a:t>
             </a:r>
+            <a:endParaRPr lang="en-US"/>
           </a:p>
           <a:p>
             <a:pPr lvl="4"/>
@@ -2656,6 +2641,7 @@
               <a:rPr lang="en-US"/>
               <a:t>Fifth level</a:t>
             </a:r>
+            <a:endParaRPr lang="en-US"/>
           </a:p>
         </p:txBody>
       </p:sp>
@@ -2680,7 +2666,6 @@
           <a:p>
             <a:fld id="{B51AB6BE-0945-437C-998D-2F62DBC41F2B}" type="datetimeFigureOut">
               <a:rPr lang="en-US" smtClean="0"/>
-              <a:t>3/17/2023</a:t>
             </a:fld>
             <a:endParaRPr lang="en-US"/>
           </a:p>
@@ -2730,18 +2715,12 @@
           <a:p>
             <a:fld id="{8E054A1B-CB68-4761-8B43-A0576DD5869E}" type="slidenum">
               <a:rPr lang="en-US" smtClean="0"/>
-              <a:t>‹#›</a:t>
             </a:fld>
             <a:endParaRPr lang="en-US"/>
           </a:p>
         </p:txBody>
       </p:sp>
     </p:spTree>
-    <p:extLst>
-      <p:ext uri="{BB962C8B-B14F-4D97-AF65-F5344CB8AC3E}">
-        <p14:creationId xmlns:p14="http://schemas.microsoft.com/office/powerpoint/2010/main" val="1895300086"/>
-      </p:ext>
-    </p:extLst>
   </p:cSld>
   <p:clrMapOvr>
     <a:masterClrMapping/>
@@ -2750,7 +2729,7 @@
 </file>
 
 <file path=ppt/slideLayouts/slideLayout9.xml><?xml version="1.0" encoding="utf-8"?>
-<p:sldLayout xmlns:a="http://schemas.openxmlformats.org/drawingml/2006/main" xmlns:r="http://schemas.openxmlformats.org/officeDocument/2006/relationships" xmlns:p="http://schemas.openxmlformats.org/presentationml/2006/main" showMasterSp="0" type="picTx" preserve="1">
+<p:sldLayout xmlns:a="http://schemas.openxmlformats.org/drawingml/2006/main" xmlns:r="http://schemas.openxmlformats.org/officeDocument/2006/relationships" xmlns:p="http://schemas.openxmlformats.org/presentationml/2006/main" type="picTx" preserve="1" showMasterSp="0">
   <p:cSld name="Picture with Caption">
     <p:bg>
       <p:bgRef idx="1003">
@@ -3042,6 +3021,7 @@
               <a:rPr lang="en-US"/>
               <a:t>Click to edit Master text styles</a:t>
             </a:r>
+            <a:endParaRPr lang="en-US"/>
           </a:p>
         </p:txBody>
       </p:sp>
@@ -3078,6 +3058,7 @@
               <a:rPr lang="en-US"/>
               <a:t>Click to edit Master title style</a:t>
             </a:r>
+            <a:endParaRPr lang="en-US"/>
           </a:p>
         </p:txBody>
       </p:sp>
@@ -3151,7 +3132,6 @@
           <a:p>
             <a:fld id="{B51AB6BE-0945-437C-998D-2F62DBC41F2B}" type="datetimeFigureOut">
               <a:rPr lang="en-US" smtClean="0"/>
-              <a:t>3/17/2023</a:t>
             </a:fld>
             <a:endParaRPr lang="en-US"/>
           </a:p>
@@ -3183,7 +3163,6 @@
           <a:p>
             <a:fld id="{8E054A1B-CB68-4761-8B43-A0576DD5869E}" type="slidenum">
               <a:rPr lang="en-US" smtClean="0"/>
-              <a:t>‹#›</a:t>
             </a:fld>
             <a:endParaRPr lang="en-US"/>
           </a:p>
@@ -3218,11 +3197,6 @@
         </p:txBody>
       </p:sp>
     </p:spTree>
-    <p:extLst>
-      <p:ext uri="{BB962C8B-B14F-4D97-AF65-F5344CB8AC3E}">
-        <p14:creationId xmlns:p14="http://schemas.microsoft.com/office/powerpoint/2010/main" val="2475766030"/>
-      </p:ext>
-    </p:extLst>
   </p:cSld>
   <p:clrMapOvr>
     <a:overrideClrMapping bg1="lt1" tx1="dk1" bg2="lt2" tx2="dk2" accent1="accent1" accent2="accent2" accent3="accent3" accent4="accent4" accent5="accent5" accent6="accent6" hlink="hlink" folHlink="folHlink"/>
@@ -3295,11 +3269,7 @@
           </a:extLst>
         </p:spPr>
         <p:txBody>
-          <a:bodyPr vert="horz" wrap="square" lIns="91440" tIns="45720" rIns="91440" bIns="45720" numCol="1" anchor="ctr" anchorCtr="0" compatLnSpc="1">
-            <a:prstTxWarp prst="textNoShape">
-              <a:avLst/>
-            </a:prstTxWarp>
-          </a:bodyPr>
+          <a:bodyPr vert="horz" wrap="square" lIns="91440" tIns="45720" rIns="91440" bIns="45720" numCol="1" anchor="ctr" anchorCtr="0" compatLnSpc="1"/>
           <a:lstStyle/>
           <a:p>
             <a:pPr lvl="0"/>
@@ -3307,6 +3277,7 @@
               <a:rPr lang="en-US"/>
               <a:t>Click to edit Master title style</a:t>
             </a:r>
+            <a:endParaRPr lang="en-US"/>
           </a:p>
         </p:txBody>
       </p:sp>
@@ -3353,11 +3324,7 @@
           </a:extLst>
         </p:spPr>
         <p:txBody>
-          <a:bodyPr vert="horz" wrap="square" lIns="91440" tIns="45720" rIns="91440" bIns="45720" numCol="1" anchor="t" anchorCtr="0" compatLnSpc="1">
-            <a:prstTxWarp prst="textNoShape">
-              <a:avLst/>
-            </a:prstTxWarp>
-          </a:bodyPr>
+          <a:bodyPr vert="horz" wrap="square" lIns="91440" tIns="45720" rIns="91440" bIns="45720" numCol="1" anchor="t" anchorCtr="0" compatLnSpc="1"/>
           <a:lstStyle/>
           <a:p>
             <a:pPr lvl="0"/>
@@ -3365,6 +3332,7 @@
               <a:rPr lang="en-US"/>
               <a:t>Click to edit Master text styles</a:t>
             </a:r>
+            <a:endParaRPr lang="en-US"/>
           </a:p>
           <a:p>
             <a:pPr lvl="1"/>
@@ -3372,6 +3340,7 @@
               <a:rPr lang="en-US"/>
               <a:t>Second level</a:t>
             </a:r>
+            <a:endParaRPr lang="en-US"/>
           </a:p>
           <a:p>
             <a:pPr lvl="2"/>
@@ -3379,6 +3348,7 @@
               <a:rPr lang="en-US"/>
               <a:t>Third level</a:t>
             </a:r>
+            <a:endParaRPr lang="en-US"/>
           </a:p>
           <a:p>
             <a:pPr lvl="3"/>
@@ -3386,6 +3356,7 @@
               <a:rPr lang="en-US"/>
               <a:t>Fourth level</a:t>
             </a:r>
+            <a:endParaRPr lang="en-US"/>
           </a:p>
           <a:p>
             <a:pPr lvl="4"/>
@@ -3393,6 +3364,7 @@
               <a:rPr lang="en-US"/>
               <a:t>Fifth level</a:t>
             </a:r>
+            <a:endParaRPr lang="en-US"/>
           </a:p>
         </p:txBody>
       </p:sp>
@@ -3437,7 +3409,6 @@
           <a:p>
             <a:fld id="{B51AB6BE-0945-437C-998D-2F62DBC41F2B}" type="datetimeFigureOut">
               <a:rPr lang="en-US" smtClean="0"/>
-              <a:t>3/17/2023</a:t>
             </a:fld>
             <a:endParaRPr lang="en-US"/>
           </a:p>
@@ -3673,9 +3644,6 @@
         </p:spPr>
         <p:txBody>
           <a:bodyPr vert="horz" wrap="square" lIns="91440" tIns="45720" rIns="91440" bIns="45720" numCol="1" anchor="ctr" anchorCtr="0" compatLnSpc="1">
-            <a:prstTxWarp prst="textNoShape">
-              <a:avLst/>
-            </a:prstTxWarp>
             <a:normAutofit/>
           </a:bodyPr>
           <a:lstStyle>
@@ -3691,32 +3659,26 @@
           <a:p>
             <a:fld id="{8E054A1B-CB68-4761-8B43-A0576DD5869E}" type="slidenum">
               <a:rPr lang="en-US" smtClean="0"/>
-              <a:t>‹#›</a:t>
             </a:fld>
             <a:endParaRPr lang="en-US"/>
           </a:p>
         </p:txBody>
       </p:sp>
     </p:spTree>
-    <p:extLst>
-      <p:ext uri="{BB962C8B-B14F-4D97-AF65-F5344CB8AC3E}">
-        <p14:creationId xmlns:p14="http://schemas.microsoft.com/office/powerpoint/2010/main" val="3498519961"/>
-      </p:ext>
-    </p:extLst>
   </p:cSld>
   <p:clrMap bg1="lt1" tx1="dk1" bg2="lt2" tx2="dk2" accent1="accent1" accent2="accent2" accent3="accent3" accent4="accent4" accent5="accent5" accent6="accent6" hlink="hlink" folHlink="folHlink"/>
   <p:sldLayoutIdLst>
-    <p:sldLayoutId id="2147483661" r:id="rId1"/>
-    <p:sldLayoutId id="2147483662" r:id="rId2"/>
-    <p:sldLayoutId id="2147483663" r:id="rId3"/>
-    <p:sldLayoutId id="2147483664" r:id="rId4"/>
-    <p:sldLayoutId id="2147483665" r:id="rId5"/>
-    <p:sldLayoutId id="2147483666" r:id="rId6"/>
-    <p:sldLayoutId id="2147483667" r:id="rId7"/>
-    <p:sldLayoutId id="2147483668" r:id="rId8"/>
-    <p:sldLayoutId id="2147483669" r:id="rId9"/>
-    <p:sldLayoutId id="2147483670" r:id="rId10"/>
-    <p:sldLayoutId id="2147483671" r:id="rId11"/>
+    <p:sldLayoutId id="2147483649" r:id="rId1"/>
+    <p:sldLayoutId id="2147483650" r:id="rId2"/>
+    <p:sldLayoutId id="2147483651" r:id="rId3"/>
+    <p:sldLayoutId id="2147483652" r:id="rId4"/>
+    <p:sldLayoutId id="2147483653" r:id="rId5"/>
+    <p:sldLayoutId id="2147483654" r:id="rId6"/>
+    <p:sldLayoutId id="2147483655" r:id="rId7"/>
+    <p:sldLayoutId id="2147483656" r:id="rId8"/>
+    <p:sldLayoutId id="2147483657" r:id="rId9"/>
+    <p:sldLayoutId id="2147483658" r:id="rId10"/>
+    <p:sldLayoutId id="2147483659" r:id="rId11"/>
   </p:sldLayoutIdLst>
   <p:txStyles>
     <p:titleStyle>
@@ -3747,7 +3709,7 @@
           <a:solidFill>
             <a:schemeClr val="tx2"/>
           </a:solidFill>
-          <a:latin typeface="Tw Cen MT" pitchFamily="34" charset="0"/>
+          <a:latin typeface="Tw Cen MT" panose="020B0602020104020603" pitchFamily="34" charset="0"/>
         </a:defRPr>
       </a:lvl2pPr>
       <a:lvl3pPr algn="l" rtl="0" eaLnBrk="1" fontAlgn="base" hangingPunct="1">
@@ -3761,7 +3723,7 @@
           <a:solidFill>
             <a:schemeClr val="tx2"/>
           </a:solidFill>
-          <a:latin typeface="Tw Cen MT" pitchFamily="34" charset="0"/>
+          <a:latin typeface="Tw Cen MT" panose="020B0602020104020603" pitchFamily="34" charset="0"/>
         </a:defRPr>
       </a:lvl3pPr>
       <a:lvl4pPr algn="l" rtl="0" eaLnBrk="1" fontAlgn="base" hangingPunct="1">
@@ -3775,7 +3737,7 @@
           <a:solidFill>
             <a:schemeClr val="tx2"/>
           </a:solidFill>
-          <a:latin typeface="Tw Cen MT" pitchFamily="34" charset="0"/>
+          <a:latin typeface="Tw Cen MT" panose="020B0602020104020603" pitchFamily="34" charset="0"/>
         </a:defRPr>
       </a:lvl4pPr>
       <a:lvl5pPr algn="l" rtl="0" eaLnBrk="1" fontAlgn="base" hangingPunct="1">
@@ -3789,7 +3751,7 @@
           <a:solidFill>
             <a:schemeClr val="tx2"/>
           </a:solidFill>
-          <a:latin typeface="Tw Cen MT" pitchFamily="34" charset="0"/>
+          <a:latin typeface="Tw Cen MT" panose="020B0602020104020603" pitchFamily="34" charset="0"/>
         </a:defRPr>
       </a:lvl5pPr>
       <a:lvl6pPr marL="457200" algn="l" rtl="0" eaLnBrk="1" fontAlgn="base" hangingPunct="1">
@@ -3803,7 +3765,7 @@
           <a:solidFill>
             <a:schemeClr val="tx2"/>
           </a:solidFill>
-          <a:latin typeface="Tw Cen MT" pitchFamily="34" charset="0"/>
+          <a:latin typeface="Tw Cen MT" panose="020B0602020104020603" pitchFamily="34" charset="0"/>
         </a:defRPr>
       </a:lvl6pPr>
       <a:lvl7pPr marL="914400" algn="l" rtl="0" eaLnBrk="1" fontAlgn="base" hangingPunct="1">
@@ -3817,7 +3779,7 @@
           <a:solidFill>
             <a:schemeClr val="tx2"/>
           </a:solidFill>
-          <a:latin typeface="Tw Cen MT" pitchFamily="34" charset="0"/>
+          <a:latin typeface="Tw Cen MT" panose="020B0602020104020603" pitchFamily="34" charset="0"/>
         </a:defRPr>
       </a:lvl7pPr>
       <a:lvl8pPr marL="1371600" algn="l" rtl="0" eaLnBrk="1" fontAlgn="base" hangingPunct="1">
@@ -3831,7 +3793,7 @@
           <a:solidFill>
             <a:schemeClr val="tx2"/>
           </a:solidFill>
-          <a:latin typeface="Tw Cen MT" pitchFamily="34" charset="0"/>
+          <a:latin typeface="Tw Cen MT" panose="020B0602020104020603" pitchFamily="34" charset="0"/>
         </a:defRPr>
       </a:lvl8pPr>
       <a:lvl9pPr marL="1828800" algn="l" rtl="0" eaLnBrk="1" fontAlgn="base" hangingPunct="1">
@@ -3845,12 +3807,12 @@
           <a:solidFill>
             <a:schemeClr val="tx2"/>
           </a:solidFill>
-          <a:latin typeface="Tw Cen MT" pitchFamily="34" charset="0"/>
+          <a:latin typeface="Tw Cen MT" panose="020B0602020104020603" pitchFamily="34" charset="0"/>
         </a:defRPr>
       </a:lvl9pPr>
     </p:titleStyle>
     <p:bodyStyle>
-      <a:lvl1pPr marL="319088" indent="-319088" algn="l" rtl="0" eaLnBrk="1" fontAlgn="base" hangingPunct="1">
+      <a:lvl1pPr marL="319405" indent="-319405" algn="l" rtl="0" eaLnBrk="1" fontAlgn="base" hangingPunct="1">
         <a:spcBef>
           <a:spcPts val="700"/>
         </a:spcBef>
@@ -3872,7 +3834,7 @@
           <a:cs typeface="+mn-cs"/>
         </a:defRPr>
       </a:lvl1pPr>
-      <a:lvl2pPr marL="639763" indent="-273050" algn="l" rtl="0" eaLnBrk="1" fontAlgn="base" hangingPunct="1">
+      <a:lvl2pPr marL="640080" indent="-273050" algn="l" rtl="0" eaLnBrk="1" fontAlgn="base" hangingPunct="1">
         <a:spcBef>
           <a:spcPts val="550"/>
         </a:spcBef>
@@ -4188,15 +4150,11 @@
               <a:rPr lang="en-US" dirty="0"/>
               <a:t>P.J. Okoth</a:t>
             </a:r>
+            <a:endParaRPr lang="en-US" dirty="0"/>
           </a:p>
         </p:txBody>
       </p:sp>
     </p:spTree>
-    <p:extLst>
-      <p:ext uri="{BB962C8B-B14F-4D97-AF65-F5344CB8AC3E}">
-        <p14:creationId xmlns:p14="http://schemas.microsoft.com/office/powerpoint/2010/main" val="235539278"/>
-      </p:ext>
-    </p:extLst>
   </p:cSld>
   <p:clrMapOvr>
     <a:masterClrMapping/>
@@ -4270,6 +4228,7 @@
               <a:rPr lang="en-US" dirty="0"/>
               <a:t>the ligament, located in the center of the knee, that controls rotation and forward movement of the tibia (shin bone) </a:t>
             </a:r>
+            <a:endParaRPr lang="en-US" dirty="0"/>
           </a:p>
           <a:p>
             <a:r>
@@ -4283,18 +4242,14 @@
               <a:rPr lang="en-US" dirty="0"/>
               <a:t>inflammation of a joint, usually accompanied by pain, swelling, and sometimes change in structure </a:t>
             </a:r>
-          </a:p>
-          <a:p>
             <a:endParaRPr lang="en-US" dirty="0"/>
           </a:p>
+          <a:p>
+            <a:endParaRPr lang="en-US" dirty="0"/>
+          </a:p>
         </p:txBody>
       </p:sp>
     </p:spTree>
-    <p:extLst>
-      <p:ext uri="{BB962C8B-B14F-4D97-AF65-F5344CB8AC3E}">
-        <p14:creationId xmlns:p14="http://schemas.microsoft.com/office/powerpoint/2010/main" val="260709099"/>
-      </p:ext>
-    </p:extLst>
   </p:cSld>
   <p:clrMapOvr>
     <a:masterClrMapping/>
@@ -4321,13 +4276,7 @@
       </p:grpSpPr>
       <p:sp>
         <p:nvSpPr>
-          <p:cNvPr id="2" name="Title 1">
-            <a:extLst>
-              <a:ext uri="{FF2B5EF4-FFF2-40B4-BE49-F238E27FC236}">
-                <a16:creationId xmlns:a16="http://schemas.microsoft.com/office/drawing/2014/main" id="{DE94D9D4-F9F7-7AA4-F97D-63FF2552FFA7}"/>
-              </a:ext>
-            </a:extLst>
-          </p:cNvPr>
+          <p:cNvPr id="2" name="Title 1"/>
           <p:cNvSpPr>
             <a:spLocks noGrp="1"/>
           </p:cNvSpPr>
@@ -4344,19 +4293,13 @@
               <a:rPr lang="en-US" dirty="0"/>
               <a:t>Terminology </a:t>
             </a:r>
-            <a:endParaRPr lang="en-KE" dirty="0"/>
-          </a:p>
-        </p:txBody>
-      </p:sp>
-      <p:sp>
-        <p:nvSpPr>
-          <p:cNvPr id="3" name="Content Placeholder 2">
-            <a:extLst>
-              <a:ext uri="{FF2B5EF4-FFF2-40B4-BE49-F238E27FC236}">
-                <a16:creationId xmlns:a16="http://schemas.microsoft.com/office/drawing/2014/main" id="{91B59D95-D420-6A0B-0592-1E9933362004}"/>
-              </a:ext>
-            </a:extLst>
-          </p:cNvPr>
+            <a:endParaRPr lang="en-US" dirty="0"/>
+          </a:p>
+        </p:txBody>
+      </p:sp>
+      <p:sp>
+        <p:nvSpPr>
+          <p:cNvPr id="3" name="Content Placeholder 2"/>
           <p:cNvSpPr>
             <a:spLocks noGrp="1"/>
           </p:cNvSpPr>
@@ -4384,6 +4327,7 @@
               <a:rPr lang="en-US" dirty="0"/>
               <a:t>A structural break in the continuity of a bone, epiphysial plate, or cartilaginous joint surface.</a:t>
             </a:r>
+            <a:endParaRPr lang="en-US" dirty="0"/>
           </a:p>
           <a:p>
             <a:r>
@@ -4394,6 +4338,7 @@
               <a:rPr lang="en-US" dirty="0"/>
               <a:t> – fracture of a bone that involves a dislocation of an adjacent articulation of that bone. </a:t>
             </a:r>
+            <a:endParaRPr lang="en-US" dirty="0"/>
           </a:p>
           <a:p>
             <a:r>
@@ -4404,6 +4349,7 @@
               <a:rPr lang="en-US" dirty="0"/>
               <a:t> – complete displacement of bone from its normal position at the joint surface, disrupting the articulation and altering the alignment of the joint. </a:t>
             </a:r>
+            <a:endParaRPr lang="en-US" dirty="0"/>
           </a:p>
           <a:p>
             <a:r>
@@ -4414,16 +4360,11 @@
               <a:rPr lang="en-US" dirty="0"/>
               <a:t> – incomplete or partial dislocation.</a:t>
             </a:r>
-            <a:endParaRPr lang="en-KE" dirty="0"/>
+            <a:endParaRPr lang="en-US" dirty="0"/>
           </a:p>
         </p:txBody>
       </p:sp>
     </p:spTree>
-    <p:extLst>
-      <p:ext uri="{BB962C8B-B14F-4D97-AF65-F5344CB8AC3E}">
-        <p14:creationId xmlns:p14="http://schemas.microsoft.com/office/powerpoint/2010/main" val="1639340008"/>
-      </p:ext>
-    </p:extLst>
   </p:cSld>
   <p:clrMapOvr>
     <a:masterClrMapping/>
@@ -4507,6 +4448,7 @@
               <a:rPr lang="en-US" dirty="0"/>
               <a:t>) which is inserted into the joint through a small incision in the joint. </a:t>
             </a:r>
+            <a:endParaRPr lang="en-US" dirty="0"/>
           </a:p>
           <a:p>
             <a:r>
@@ -4524,6 +4466,7 @@
               <a:rPr lang="en-US" dirty="0"/>
               <a:t>a sac filled with fluid between a bone and a tendon or muscle </a:t>
             </a:r>
+            <a:endParaRPr lang="en-US" dirty="0"/>
           </a:p>
           <a:p>
             <a:r>
@@ -4537,6 +4480,7 @@
               <a:rPr lang="en-US" dirty="0"/>
               <a:t>Inflammation of a bursa. Occurs as a result of repeated small stresses and overuse that cause the bursa to swell and become irritated.</a:t>
             </a:r>
+            <a:endParaRPr lang="en-US" dirty="0"/>
           </a:p>
           <a:p>
             <a:pPr marL="0" indent="0">
@@ -4547,11 +4491,6 @@
         </p:txBody>
       </p:sp>
     </p:spTree>
-    <p:extLst>
-      <p:ext uri="{BB962C8B-B14F-4D97-AF65-F5344CB8AC3E}">
-        <p14:creationId xmlns:p14="http://schemas.microsoft.com/office/powerpoint/2010/main" val="2296508204"/>
-      </p:ext>
-    </p:extLst>
   </p:cSld>
   <p:clrMapOvr>
     <a:masterClrMapping/>
@@ -4630,10 +4569,17 @@
                   <a:srgbClr val="202124"/>
                 </a:solidFill>
                 <a:effectLst/>
-                <a:latin typeface="arial" panose="020B0604020202020204" pitchFamily="34" charset="0"/>
+                <a:latin typeface="Arial" panose="02080604020202020204" pitchFamily="34" charset="0"/>
               </a:rPr>
               <a:t>a localized physical condition in which part of the body becomes reddened, swollen, hot, and often painful, especially as a reaction to injury or infection.</a:t>
             </a:r>
+            <a:endParaRPr lang="en-US" b="0" i="0" dirty="0">
+              <a:solidFill>
+                <a:srgbClr val="202124"/>
+              </a:solidFill>
+              <a:effectLst/>
+              <a:latin typeface="Arial" panose="02080604020202020204" pitchFamily="34" charset="0"/>
+            </a:endParaRPr>
           </a:p>
           <a:p>
             <a:r>
@@ -4651,6 +4597,7 @@
               <a:rPr lang="en-US" dirty="0"/>
               <a:t>where the ends of two or more bones meet </a:t>
             </a:r>
+            <a:endParaRPr lang="en-US" dirty="0"/>
           </a:p>
           <a:p>
             <a:r>
@@ -4664,6 +4611,7 @@
               <a:rPr lang="en-US" dirty="0"/>
               <a:t>a white, shiny, flexible band of fibrous tissue that binds joints together and connects various bones and cartilage </a:t>
             </a:r>
+            <a:endParaRPr lang="en-US" dirty="0"/>
           </a:p>
           <a:p>
             <a:pPr marL="0" indent="0">
@@ -4674,11 +4622,6 @@
         </p:txBody>
       </p:sp>
     </p:spTree>
-    <p:extLst>
-      <p:ext uri="{BB962C8B-B14F-4D97-AF65-F5344CB8AC3E}">
-        <p14:creationId xmlns:p14="http://schemas.microsoft.com/office/powerpoint/2010/main" val="2291928039"/>
-      </p:ext>
-    </p:extLst>
   </p:cSld>
   <p:clrMapOvr>
     <a:masterClrMapping/>
@@ -4758,6 +4701,7 @@
               <a:rPr lang="en-US" dirty="0"/>
               <a:t>two crescent-shaped discs of connective tissue between the bones of the knees that act as shock absorbers to cushion the lower part of the leg from the weight of the rest of the body </a:t>
             </a:r>
+            <a:endParaRPr lang="en-US" dirty="0"/>
           </a:p>
           <a:p>
             <a:r>
@@ -4775,6 +4719,7 @@
               <a:rPr lang="en-US" dirty="0"/>
               <a:t>a clear, sticky fluid that is released by the synovial membrane and acts as a lubricant for joints and tendons </a:t>
             </a:r>
+            <a:endParaRPr lang="en-US" dirty="0"/>
           </a:p>
           <a:p>
             <a:r>
@@ -4792,6 +4737,7 @@
               <a:rPr lang="en-US" dirty="0"/>
               <a:t>the tough cords of the tissue that connect muscles to bones </a:t>
             </a:r>
+            <a:endParaRPr lang="en-US" dirty="0"/>
           </a:p>
           <a:p>
             <a:r>
@@ -4817,11 +4763,6 @@
         </p:txBody>
       </p:sp>
     </p:spTree>
-    <p:extLst>
-      <p:ext uri="{BB962C8B-B14F-4D97-AF65-F5344CB8AC3E}">
-        <p14:creationId xmlns:p14="http://schemas.microsoft.com/office/powerpoint/2010/main" val="2971596797"/>
-      </p:ext>
-    </p:extLst>
   </p:cSld>
   <p:clrMapOvr>
     <a:masterClrMapping/>
@@ -4931,6 +4872,7 @@
               <a:rPr lang="en-US" dirty="0"/>
               <a:t>a condition that develops when bone is no longer replaced as quickly as it is removed</a:t>
             </a:r>
+            <a:endParaRPr lang="en-US" dirty="0"/>
           </a:p>
           <a:p>
             <a:pPr marL="0" indent="0">
@@ -4944,11 +4886,6 @@
         </p:txBody>
       </p:sp>
     </p:spTree>
-    <p:extLst>
-      <p:ext uri="{BB962C8B-B14F-4D97-AF65-F5344CB8AC3E}">
-        <p14:creationId xmlns:p14="http://schemas.microsoft.com/office/powerpoint/2010/main" val="1467985697"/>
-      </p:ext>
-    </p:extLst>
   </p:cSld>
   <p:clrMapOvr>
     <a:masterClrMapping/>
@@ -5019,6 +4956,7 @@
               <a:rPr lang="en-US" dirty="0"/>
               <a:t>: surgical removal of a limb or body part</a:t>
             </a:r>
+            <a:endParaRPr lang="en-US" dirty="0"/>
           </a:p>
           <a:p>
             <a:r>
@@ -5029,6 +4967,7 @@
               <a:rPr lang="en-CA" dirty="0"/>
               <a:t>: incision into a joint</a:t>
             </a:r>
+            <a:endParaRPr lang="en-CA" dirty="0"/>
           </a:p>
           <a:p>
             <a:r>
@@ -5039,6 +4978,7 @@
               <a:rPr lang="en-CA" dirty="0"/>
               <a:t>: fusion of a joint</a:t>
             </a:r>
+            <a:endParaRPr lang="en-CA" dirty="0"/>
           </a:p>
           <a:p>
             <a:r>
@@ -5049,6 +4989,7 @@
               <a:rPr lang="en-CA" dirty="0"/>
               <a:t>: visualizing the inside of a joint with the use of an instrument through a small incision</a:t>
             </a:r>
+            <a:endParaRPr lang="en-CA" dirty="0"/>
           </a:p>
           <a:p>
             <a:endParaRPr lang="en-US" dirty="0"/>
@@ -5056,11 +4997,6 @@
         </p:txBody>
       </p:sp>
     </p:spTree>
-    <p:extLst>
-      <p:ext uri="{BB962C8B-B14F-4D97-AF65-F5344CB8AC3E}">
-        <p14:creationId xmlns:p14="http://schemas.microsoft.com/office/powerpoint/2010/main" val="1630057942"/>
-      </p:ext>
-    </p:extLst>
   </p:cSld>
   <p:clrMapOvr>
     <a:masterClrMapping/>
@@ -5136,6 +5072,7 @@
               <a:rPr lang="en-CA" dirty="0"/>
               <a:t> - bone</a:t>
             </a:r>
+            <a:endParaRPr lang="en-CA" dirty="0"/>
           </a:p>
           <a:p>
             <a:r>
@@ -5146,6 +5083,7 @@
               <a:rPr lang="en-CA" dirty="0"/>
               <a:t> – cartilage</a:t>
             </a:r>
+            <a:endParaRPr lang="en-CA" dirty="0"/>
           </a:p>
           <a:p>
             <a:r>
@@ -5156,6 +5094,7 @@
               <a:rPr lang="en-CA" dirty="0"/>
               <a:t> – cutting of a bone</a:t>
             </a:r>
+            <a:endParaRPr lang="en-CA" dirty="0"/>
           </a:p>
           <a:p>
             <a:r>
@@ -5166,6 +5105,7 @@
               <a:rPr lang="en-CA" dirty="0"/>
               <a:t> – increased bone density</a:t>
             </a:r>
+            <a:endParaRPr lang="en-CA" dirty="0"/>
           </a:p>
           <a:p>
             <a:r>
@@ -5176,6 +5116,7 @@
               <a:rPr lang="en-CA" dirty="0"/>
               <a:t> – bone dissolution, especially the loss of calcium. E.g. Punched out osteolytic lesions in multiple myeloma.</a:t>
             </a:r>
+            <a:endParaRPr lang="en-CA" dirty="0"/>
           </a:p>
           <a:p>
             <a:endParaRPr lang="en-US" dirty="0"/>
@@ -5183,11 +5124,6 @@
         </p:txBody>
       </p:sp>
     </p:spTree>
-    <p:extLst>
-      <p:ext uri="{BB962C8B-B14F-4D97-AF65-F5344CB8AC3E}">
-        <p14:creationId xmlns:p14="http://schemas.microsoft.com/office/powerpoint/2010/main" val="788895646"/>
-      </p:ext>
-    </p:extLst>
   </p:cSld>
   <p:clrMapOvr>
     <a:masterClrMapping/>
@@ -5214,13 +5150,7 @@
       </p:grpSpPr>
       <p:sp>
         <p:nvSpPr>
-          <p:cNvPr id="2" name="Title 1">
-            <a:extLst>
-              <a:ext uri="{FF2B5EF4-FFF2-40B4-BE49-F238E27FC236}">
-                <a16:creationId xmlns:a16="http://schemas.microsoft.com/office/drawing/2014/main" id="{8079AC69-46EA-154B-76F0-D9FA6B09E4B6}"/>
-              </a:ext>
-            </a:extLst>
-          </p:cNvPr>
+          <p:cNvPr id="2" name="Title 1"/>
           <p:cNvSpPr>
             <a:spLocks noGrp="1"/>
           </p:cNvSpPr>
@@ -5237,19 +5167,13 @@
               <a:rPr lang="en-US" dirty="0"/>
               <a:t>Terminology </a:t>
             </a:r>
-            <a:endParaRPr lang="en-KE" dirty="0"/>
-          </a:p>
-        </p:txBody>
-      </p:sp>
-      <p:sp>
-        <p:nvSpPr>
-          <p:cNvPr id="3" name="Content Placeholder 2">
-            <a:extLst>
-              <a:ext uri="{FF2B5EF4-FFF2-40B4-BE49-F238E27FC236}">
-                <a16:creationId xmlns:a16="http://schemas.microsoft.com/office/drawing/2014/main" id="{619F822D-9332-7CD3-9FA5-4C23E89BBD96}"/>
-              </a:ext>
-            </a:extLst>
-          </p:cNvPr>
+            <a:endParaRPr lang="en-US" dirty="0"/>
+          </a:p>
+        </p:txBody>
+      </p:sp>
+      <p:sp>
+        <p:nvSpPr>
+          <p:cNvPr id="3" name="Content Placeholder 2"/>
           <p:cNvSpPr>
             <a:spLocks noGrp="1"/>
           </p:cNvSpPr>
@@ -5270,6 +5194,7 @@
               <a:rPr lang="en-CA" dirty="0"/>
               <a:t> – generalized loss of bone density as a result of loss of bone tissue. It occurs when the creation of new bone does not keep up with the loss of old bone. Bones become weak and brittle.</a:t>
             </a:r>
+            <a:endParaRPr lang="en-CA" dirty="0"/>
           </a:p>
           <a:p>
             <a:r>
@@ -5280,16 +5205,11 @@
               <a:rPr lang="en-CA" dirty="0"/>
               <a:t> of bone – loss of bone density</a:t>
             </a:r>
-            <a:endParaRPr lang="en-KE" dirty="0"/>
+            <a:endParaRPr lang="en-US" dirty="0"/>
           </a:p>
         </p:txBody>
       </p:sp>
     </p:spTree>
-    <p:extLst>
-      <p:ext uri="{BB962C8B-B14F-4D97-AF65-F5344CB8AC3E}">
-        <p14:creationId xmlns:p14="http://schemas.microsoft.com/office/powerpoint/2010/main" val="97498623"/>
-      </p:ext>
-    </p:extLst>
   </p:cSld>
   <p:clrMapOvr>
     <a:masterClrMapping/>
@@ -5361,11 +5281,6 @@
         </p:txBody>
       </p:sp>
     </p:spTree>
-    <p:extLst>
-      <p:ext uri="{BB962C8B-B14F-4D97-AF65-F5344CB8AC3E}">
-        <p14:creationId xmlns:p14="http://schemas.microsoft.com/office/powerpoint/2010/main" val="1195687463"/>
-      </p:ext>
-    </p:extLst>
   </p:cSld>
   <p:clrMapOvr>
     <a:masterClrMapping/>
@@ -5437,18 +5352,21 @@
               <a:rPr lang="en-US" dirty="0"/>
               <a:t>Orthopaedics is the branch of surgery that deals with diseases and injuries of the trunk and limbs.</a:t>
             </a:r>
+            <a:endParaRPr lang="en-US" dirty="0"/>
           </a:p>
           <a:p>
             <a:r>
               <a:rPr lang="en-US" dirty="0"/>
               <a:t>Deals with conditions affecting bones, joints, muscles, tendons, ligaments, bursae, nerves, and blood vessels.</a:t>
             </a:r>
+            <a:endParaRPr lang="en-US" dirty="0"/>
           </a:p>
           <a:p>
             <a:r>
               <a:rPr lang="en-US" dirty="0"/>
               <a:t>“Orthopaedic” is derived from Greek words meaning ‘straight child’. Originally dealt with the art of correcting deformities in children.</a:t>
             </a:r>
+            <a:endParaRPr lang="en-US" dirty="0"/>
           </a:p>
           <a:p>
             <a:r>
@@ -5464,11 +5382,6 @@
         </p:txBody>
       </p:sp>
     </p:spTree>
-    <p:extLst>
-      <p:ext uri="{BB962C8B-B14F-4D97-AF65-F5344CB8AC3E}">
-        <p14:creationId xmlns:p14="http://schemas.microsoft.com/office/powerpoint/2010/main" val="68106924"/>
-      </p:ext>
-    </p:extLst>
   </p:cSld>
   <p:clrMapOvr>
     <a:masterClrMapping/>
@@ -5495,13 +5408,7 @@
       </p:grpSpPr>
       <p:sp>
         <p:nvSpPr>
-          <p:cNvPr id="2" name="Title 1">
-            <a:extLst>
-              <a:ext uri="{FF2B5EF4-FFF2-40B4-BE49-F238E27FC236}">
-                <a16:creationId xmlns:a16="http://schemas.microsoft.com/office/drawing/2014/main" id="{DA4EF13D-1B62-8C57-1D88-5074D0507CB2}"/>
-              </a:ext>
-            </a:extLst>
-          </p:cNvPr>
+          <p:cNvPr id="2" name="Title 1"/>
           <p:cNvSpPr>
             <a:spLocks noGrp="1"/>
           </p:cNvSpPr>
@@ -5518,19 +5425,13 @@
               <a:rPr lang="en-US" dirty="0"/>
               <a:t>Traumatology </a:t>
             </a:r>
-            <a:endParaRPr lang="en-KE" dirty="0"/>
-          </a:p>
-        </p:txBody>
-      </p:sp>
-      <p:sp>
-        <p:nvSpPr>
-          <p:cNvPr id="3" name="Content Placeholder 2">
-            <a:extLst>
-              <a:ext uri="{FF2B5EF4-FFF2-40B4-BE49-F238E27FC236}">
-                <a16:creationId xmlns:a16="http://schemas.microsoft.com/office/drawing/2014/main" id="{015DBDAC-307B-DB8B-DE08-2B55D80BEC44}"/>
-              </a:ext>
-            </a:extLst>
-          </p:cNvPr>
+            <a:endParaRPr lang="en-US" dirty="0"/>
+          </a:p>
+        </p:txBody>
+      </p:sp>
+      <p:sp>
+        <p:nvSpPr>
+          <p:cNvPr id="3" name="Content Placeholder 2"/>
           <p:cNvSpPr>
             <a:spLocks noGrp="1"/>
           </p:cNvSpPr>
@@ -5562,16 +5463,11 @@
                 <a:latin typeface="Open Sans" panose="020B0606030504020204" pitchFamily="34" charset="0"/>
               </a:rPr>
             </a:br>
-            <a:endParaRPr lang="en-KE" dirty="0"/>
+            <a:endParaRPr lang="en-US" dirty="0"/>
           </a:p>
         </p:txBody>
       </p:sp>
     </p:spTree>
-    <p:extLst>
-      <p:ext uri="{BB962C8B-B14F-4D97-AF65-F5344CB8AC3E}">
-        <p14:creationId xmlns:p14="http://schemas.microsoft.com/office/powerpoint/2010/main" val="1257622101"/>
-      </p:ext>
-    </p:extLst>
   </p:cSld>
   <p:clrMapOvr>
     <a:masterClrMapping/>
@@ -5638,24 +5534,28 @@
               <a:rPr lang="en-CA" dirty="0"/>
               <a:t>The treatment of fractures on a precise scientific basis became possible when adequate radiographic techniques became available.</a:t>
             </a:r>
+            <a:endParaRPr lang="en-CA" dirty="0"/>
           </a:p>
           <a:p>
             <a:r>
               <a:rPr lang="en-CA" dirty="0"/>
               <a:t>Roentgen discovered X-rays in 1895, but several years passed before the necessary apparatus was developed for clinical use.</a:t>
             </a:r>
+            <a:endParaRPr lang="en-CA" dirty="0"/>
           </a:p>
           <a:p>
             <a:r>
               <a:rPr lang="en-CA" dirty="0"/>
               <a:t>The use of x-rays in fracture treatment began in the early 1900s.</a:t>
             </a:r>
+            <a:endParaRPr lang="en-CA" dirty="0"/>
           </a:p>
           <a:p>
             <a:r>
               <a:rPr lang="en-CA" dirty="0"/>
               <a:t>It is in the 1900s also that surgeons began to think more in terms of open operations in the treatment of difficult fractures.</a:t>
             </a:r>
+            <a:endParaRPr lang="en-CA" dirty="0"/>
           </a:p>
           <a:p>
             <a:endParaRPr lang="en-US" dirty="0"/>
@@ -5663,11 +5563,6 @@
         </p:txBody>
       </p:sp>
     </p:spTree>
-    <p:extLst>
-      <p:ext uri="{BB962C8B-B14F-4D97-AF65-F5344CB8AC3E}">
-        <p14:creationId xmlns:p14="http://schemas.microsoft.com/office/powerpoint/2010/main" val="1870239505"/>
-      </p:ext>
-    </p:extLst>
   </p:cSld>
   <p:clrMapOvr>
     <a:masterClrMapping/>
@@ -5736,18 +5631,21 @@
               <a:rPr lang="en-CA" dirty="0"/>
               <a:t>Antiseptic surgery was introduced by Lister in 1867</a:t>
             </a:r>
+            <a:endParaRPr lang="en-CA" dirty="0"/>
           </a:p>
           <a:p>
             <a:r>
               <a:rPr lang="en-CA" dirty="0"/>
               <a:t>Later on aseptic surgery emerged.</a:t>
             </a:r>
+            <a:endParaRPr lang="en-CA" dirty="0"/>
           </a:p>
           <a:p>
             <a:r>
               <a:rPr lang="en-CA" dirty="0"/>
               <a:t>Before then, infection paused a great danger to most open operations.</a:t>
             </a:r>
+            <a:endParaRPr lang="en-CA" dirty="0"/>
           </a:p>
           <a:p>
             <a:endParaRPr lang="en-US" dirty="0"/>
@@ -5755,11 +5653,6 @@
         </p:txBody>
       </p:sp>
     </p:spTree>
-    <p:extLst>
-      <p:ext uri="{BB962C8B-B14F-4D97-AF65-F5344CB8AC3E}">
-        <p14:creationId xmlns:p14="http://schemas.microsoft.com/office/powerpoint/2010/main" val="1383134225"/>
-      </p:ext>
-    </p:extLst>
   </p:cSld>
   <p:clrMapOvr>
     <a:masterClrMapping/>
@@ -5826,12 +5719,14 @@
               <a:rPr lang="en-CA" dirty="0"/>
               <a:t>Operative trauma surgery was also hindered by lack of suitable implants.</a:t>
             </a:r>
+            <a:endParaRPr lang="en-CA" dirty="0"/>
           </a:p>
           <a:p>
             <a:r>
               <a:rPr lang="en-CA" dirty="0"/>
               <a:t>Iron, mild steel or silver corroded and partly dissolved away in the tissues, causing a local reaction which often hindered union.</a:t>
             </a:r>
+            <a:endParaRPr lang="en-CA" dirty="0"/>
           </a:p>
           <a:p>
             <a:r>
@@ -5843,11 +5738,6 @@
         </p:txBody>
       </p:sp>
     </p:spTree>
-    <p:extLst>
-      <p:ext uri="{BB962C8B-B14F-4D97-AF65-F5344CB8AC3E}">
-        <p14:creationId xmlns:p14="http://schemas.microsoft.com/office/powerpoint/2010/main" val="2641166976"/>
-      </p:ext>
-    </p:extLst>
   </p:cSld>
   <p:clrMapOvr>
     <a:masterClrMapping/>
@@ -5914,24 +5804,28 @@
               <a:rPr lang="en-CA" dirty="0"/>
               <a:t>Fracture treatment is guided by exercise of sound judgment, not on rigid precepts.</a:t>
             </a:r>
+            <a:endParaRPr lang="en-CA" dirty="0"/>
           </a:p>
           <a:p>
             <a:r>
               <a:rPr lang="en-CA" dirty="0"/>
               <a:t>Some fractures do not require reduction</a:t>
             </a:r>
+            <a:endParaRPr lang="en-CA" dirty="0"/>
           </a:p>
           <a:p>
             <a:r>
               <a:rPr lang="en-CA" dirty="0"/>
               <a:t>Some fractures do not need immobilization</a:t>
             </a:r>
+            <a:endParaRPr lang="en-CA" dirty="0"/>
           </a:p>
           <a:p>
             <a:r>
               <a:rPr lang="en-CA" dirty="0"/>
               <a:t>In the treatment of fractures, it is not the bone alone that matters. </a:t>
             </a:r>
+            <a:endParaRPr lang="en-CA" dirty="0"/>
           </a:p>
           <a:p>
             <a:r>
@@ -5943,11 +5837,6 @@
         </p:txBody>
       </p:sp>
     </p:spTree>
-    <p:extLst>
-      <p:ext uri="{BB962C8B-B14F-4D97-AF65-F5344CB8AC3E}">
-        <p14:creationId xmlns:p14="http://schemas.microsoft.com/office/powerpoint/2010/main" val="301905735"/>
-      </p:ext>
-    </p:extLst>
   </p:cSld>
   <p:clrMapOvr>
     <a:masterClrMapping/>
@@ -6014,12 +5903,14 @@
               <a:rPr lang="en-CA" dirty="0"/>
               <a:t>There is a shift towards the more frequent use of internal fixation as an alternative to splintage or traction, for the management of limb bone fractures.</a:t>
             </a:r>
+            <a:endParaRPr lang="en-CA" dirty="0"/>
           </a:p>
           <a:p>
             <a:r>
               <a:rPr lang="en-CA" dirty="0"/>
               <a:t>There is also improvement in the designs of external fixators.</a:t>
             </a:r>
+            <a:endParaRPr lang="en-CA" dirty="0"/>
           </a:p>
           <a:p>
             <a:r>
@@ -6031,11 +5922,6 @@
         </p:txBody>
       </p:sp>
     </p:spTree>
-    <p:extLst>
-      <p:ext uri="{BB962C8B-B14F-4D97-AF65-F5344CB8AC3E}">
-        <p14:creationId xmlns:p14="http://schemas.microsoft.com/office/powerpoint/2010/main" val="279360554"/>
-      </p:ext>
-    </p:extLst>
   </p:cSld>
   <p:clrMapOvr>
     <a:masterClrMapping/>
@@ -6102,6 +5988,7 @@
               <a:rPr lang="en-CA" dirty="0"/>
               <a:t>There have also been developments in imaging techniques that has made fracture treatment more efficient.</a:t>
             </a:r>
+            <a:endParaRPr lang="en-CA" dirty="0"/>
           </a:p>
           <a:p>
             <a:pPr lvl="1"/>
@@ -6109,6 +5996,7 @@
               <a:rPr lang="en-CA" dirty="0"/>
               <a:t>Computerised tomography (CT) scanning</a:t>
             </a:r>
+            <a:endParaRPr lang="en-CA" dirty="0"/>
           </a:p>
           <a:p>
             <a:pPr lvl="1"/>
@@ -6116,12 +6004,14 @@
               <a:rPr lang="en-CA" dirty="0"/>
               <a:t>Magnetic resonance imaging (MRI)</a:t>
             </a:r>
+            <a:endParaRPr lang="en-CA" dirty="0"/>
           </a:p>
           <a:p>
             <a:r>
               <a:rPr lang="en-CA" dirty="0"/>
               <a:t>These have improved the ability to view images of injuries of bones and joints in various dimensions.</a:t>
             </a:r>
+            <a:endParaRPr lang="en-CA" dirty="0"/>
           </a:p>
           <a:p>
             <a:r>
@@ -6133,11 +6023,6 @@
         </p:txBody>
       </p:sp>
     </p:spTree>
-    <p:extLst>
-      <p:ext uri="{BB962C8B-B14F-4D97-AF65-F5344CB8AC3E}">
-        <p14:creationId xmlns:p14="http://schemas.microsoft.com/office/powerpoint/2010/main" val="245578936"/>
-      </p:ext>
-    </p:extLst>
   </p:cSld>
   <p:clrMapOvr>
     <a:masterClrMapping/>
@@ -6372,11 +6257,9 @@
       </a:bgFillStyleLst>
     </a:fmtScheme>
   </a:themeElements>
-  <a:objectDefaults/>
-  <a:extraClrSchemeLst/>
   <a:extLst>
     <a:ext uri="{05A4C25C-085E-4340-85A3-A5531E510DB2}">
-      <thm15:themeFamily xmlns:thm15="http://schemas.microsoft.com/office/thememl/2012/main" name="Theme2" id="{090927D4-5915-4BF0-B731-6CA04EABFC92}" vid="{827BE963-2D70-4983-BDB0-E138C0FA11EC}"/>
+      <thm15:themeFamily xmlns:thm15="http://schemas.microsoft.com/office/thememl/2012/main" name="Office Theme" id="{62F939B6-93AF-4DB8-9C6B-D6C7DFDC589F}" vid="{4A3C46E8-61CC-4603-A589-7422A47A8E4A}"/>
     </a:ext>
   </a:extLst>
 </a:theme>

</xml_diff>